<commit_message>
Claim support and judge support reported as ranges over evaluation runs (0.86-0.905, 97.5-100%) with a note on LLM run-to-run variance; app logs and shows the duration model status
Co-Authored-By: Claude Opus 5.5 <noreply@anthropic.com>
</commit_message>
<xml_diff>
--- a/slides/procurement_intelligence.pptx
+++ b/slides/procurement_intelligence.pptx
@@ -124,7 +124,7 @@
   <p:extLst>
     <p:ext uri="{521415D9-36F7-43E2-AB2F-B90AF26B5E84}">
       <p14:sectionLst xmlns:p14="http://schemas.microsoft.com/office/powerpoint/2010/main">
-        <p14:section name="Opening" id="{6cf45d1a-f60d-e730-6e6a-5a47c4b32d2d}">
+        <p14:section name="Opening" id="{3e2c02d3-692d-1d77-39f9-1bdc11e3668e}">
           <p14:sldIdLst>
             <p14:sldId id="256"/>
             <p14:sldId id="257"/>
@@ -133,37 +133,37 @@
             <p14:sldId id="260"/>
           </p14:sldIdLst>
         </p14:section>
-        <p14:section name="1 Plan" id="{2378a541-b5f5-4d8d-19dc-20550258127b}">
+        <p14:section name="1 Plan" id="{fc4da16c-4ba8-7d8a-dff7-6b800d2c79f3}">
           <p14:sldIdLst>
             <p14:sldId id="261"/>
             <p14:sldId id="262"/>
             <p14:sldId id="263"/>
           </p14:sldIdLst>
         </p14:section>
-        <p14:section name="2 Tender design" id="{6c282fd6-4e8e-1798-e447-820ffd931ac2}">
+        <p14:section name="2 Tender design" id="{1045d181-2827-8924-635b-2e2fa38154b1}">
           <p14:sldIdLst>
             <p14:sldId id="264"/>
             <p14:sldId id="265"/>
           </p14:sldIdLst>
         </p14:section>
-        <p14:section name="3 Monitor" id="{5c4451d0-1d42-c805-a0fe-fde5283b740e}">
+        <p14:section name="3 Monitor" id="{06fa20ec-a5b2-fd1b-c428-70570f9d47fe}">
           <p14:sldIdLst>
             <p14:sldId id="266"/>
             <p14:sldId id="267"/>
           </p14:sldIdLst>
         </p14:section>
-        <p14:section name="4 Learn" id="{349a92a5-ca0f-a99b-b38c-63223f2f8895}">
+        <p14:section name="4 Learn" id="{b73fccff-abf8-70f4-ae97-ffd6db330a41}">
           <p14:sldIdLst>
             <p14:sldId id="268"/>
             <p14:sldId id="269"/>
           </p14:sldIdLst>
         </p14:section>
-        <p14:section name="Close" id="{f44dab39-7cdb-0bad-e2a8-07664eb07814}">
+        <p14:section name="Close" id="{af432047-f721-c04f-fbb5-012e774e70f8}">
           <p14:sldIdLst>
             <p14:sldId id="270"/>
           </p14:sldIdLst>
         </p14:section>
-        <p14:section name="Backup" id="{5936e3c9-cec4-de50-9bc1-31f11a515828}">
+        <p14:section name="Backup" id="{2f17b58c-3b7d-e3d1-09c6-5f9e86f3e717}">
           <p14:sldIdLst>
             <p14:sldId id="271"/>
             <p14:sldId id="272"/>
@@ -1908,7 +1908,7 @@
               <a:rPr lang="en-US" dirty="0"/>
               <a:t>Guardrails and conflicts (2 min). Measured on the held-out test half, notebook 61, final run 2026-10-23.
 Layers, cheapest first: the retrieval gate; evidence wrapped as data; quarantine of instruction-like passages; JSON output; mechanical checks (citation exists, every claim cited, every number ≥ 10 and project ID appears in a CITED source); then ONE batched verifier call per answer that reads each claim next to the exact text of its sources and fails closed.
-Results: citation validity 1.00; claim support 0.893 after guardrails, the verifier removed 9 of 99 claims; an independent judge found 97.5% of 40 kept claims supported; refusal accuracy 3 of 3; the planted prompt-injection passage was quarantined and its claim never appeared.
+Results: citation validity 1.00; claim support 0.86-0.905 after guardrails across the evaluation runs (the verifier removes about 6-9 claims per run); an independent judge found 97.5-100% of 40 kept claims supported; Same frozen questions and temperature 0, yet the LLM's answers and the verifier's verdicts vary slightly between runs, so answer-quality metrics are reported as the range over the 2026-10-23 evaluation runs.; refusal accuracy 3 of 3; the planted prompt-injection passage was quarantined and its claim never appeared.
 Caveat: verifier and judge are the same model family as the generator, so the judge is a second opinion, not ground truth.
 Conflicting evidence (ICR vs ISR): ratings are extracted by regex with their passage. For the final outcome, IEG review &gt; ICR &gt; latest ISR, among documents published by the as-of date; for "state at a date", the latest ISR before it. Nothing is hidden: every rating is shown with its date, and flags are raised (isr_icr_disconnect, ieg_downgrade, isr_volatility). Found: 1 IEG downgrade and 2 ISR volatility cases.</a:t>
             </a:r>
@@ -2277,7 +2277,7 @@
             <a:r>
               <a:rPr lang="en-US" dirty="0"/>
               <a:t>Rollout and KPIs (1.5 min).
-Four phases, each with go / no-go criteria decided in advance (proposed). Phase 0 is this work. Its measured status: P80 coverage 0.81 meets the target; claim support 0.893 is just under 0.9; P50 is level with the baseline rather than better; recall@5 meets the target leniently (0.83) but not strictly (0.57). So phase 0 is not a clean pass and I would say so: the next work is retrieval quality and a multilingual model before a pilot.
+Four phases, each with go / no-go criteria decided in advance (proposed). Phase 0 is this work. Its measured status: P80 coverage 0.81 meets the target; claim support 0.86-0.905 across runs sits around the 0.9 target, so not a clean pass; P50 is level with the baseline rather than better; recall@5 meets the target leniently (0.83) but not strictly (0.57). So phase 0 is not a clean pass and I would say so: the next work is retrieval quality and a multilingual model before a pilot.
 Phase 1: a 3-month shadow pilot with about 10 specialists in one region, advisory only. Exit: at least 60% weekly active, at most 5% answers flagged wrong-source, and no unsupported claim in a 100-answer audit.
 Business KPIs - planning cycle time (before/after timing), adoption, answers accepted without edit, forecast accuracy in use - are PROPOSED pilot targets. No numbers exist for them yet and I didn't invent any. The KPI dashboard already has the page for them, labelled "test usage only" until a pilot starts.</a:t>
             </a:r>
@@ -4926,7 +4926,7 @@
         <p:spPr>
           <a:xfrm>
             <a:off x="548640" y="1371600"/>
-            <a:ext cx="2560320" cy="685800"/>
+            <a:ext cx="2651760" cy="685800"/>
           </a:xfrm>
           <a:prstGeom prst="rect">
             <a:avLst/>
@@ -4965,7 +4965,7 @@
         <p:spPr>
           <a:xfrm>
             <a:off x="548640" y="2103120"/>
-            <a:ext cx="2560320" cy="548640"/>
+            <a:ext cx="2651760" cy="548640"/>
           </a:xfrm>
           <a:prstGeom prst="rect">
             <a:avLst/>
@@ -5004,7 +5004,7 @@
         <p:spPr>
           <a:xfrm>
             <a:off x="3383280" y="1371600"/>
-            <a:ext cx="2560320" cy="685800"/>
+            <a:ext cx="2651760" cy="685800"/>
           </a:xfrm>
           <a:prstGeom prst="rect">
             <a:avLst/>
@@ -5020,7 +5020,7 @@
               <a:buNone/>
             </a:pPr>
             <a:r>
-              <a:rPr lang="en-US" sz="4000" b="1" dirty="0">
+              <a:rPr lang="en-US" sz="3200" b="1" dirty="0">
                 <a:solidFill>
                   <a:srgbClr val="0F5257"/>
                 </a:solidFill>
@@ -5028,9 +5028,9 @@
                 <a:ea typeface="Cambria" pitchFamily="34" charset="-122"/>
                 <a:cs typeface="Cambria" pitchFamily="34" charset="-120"/>
               </a:rPr>
-              <a:t>0.893</a:t>
-            </a:r>
-            <a:endParaRPr lang="en-US" sz="4000" dirty="0"/>
+              <a:t>0.86–0.905</a:t>
+            </a:r>
+            <a:endParaRPr lang="en-US" sz="3200" dirty="0"/>
           </a:p>
         </p:txBody>
       </p:sp>
@@ -5043,7 +5043,7 @@
         <p:spPr>
           <a:xfrm>
             <a:off x="3383280" y="2103120"/>
-            <a:ext cx="2560320" cy="548640"/>
+            <a:ext cx="2651760" cy="548640"/>
           </a:xfrm>
           <a:prstGeom prst="rect">
             <a:avLst/>
@@ -5067,7 +5067,7 @@
                 <a:ea typeface="Calibri" pitchFamily="34" charset="-122"/>
                 <a:cs typeface="Calibri" pitchFamily="34" charset="-120"/>
               </a:rPr>
-              <a:t>claim support after guardrails (9 of 99 claims removed)</a:t>
+              <a:t>claim support after guardrails (range over evaluation runs)</a:t>
             </a:r>
             <a:endParaRPr lang="en-US" sz="1400" dirty="0"/>
           </a:p>
@@ -5082,7 +5082,7 @@
         <p:spPr>
           <a:xfrm>
             <a:off x="6217920" y="1371600"/>
-            <a:ext cx="2560320" cy="685800"/>
+            <a:ext cx="2651760" cy="685800"/>
           </a:xfrm>
           <a:prstGeom prst="rect">
             <a:avLst/>
@@ -5098,7 +5098,7 @@
               <a:buNone/>
             </a:pPr>
             <a:r>
-              <a:rPr lang="en-US" sz="4000" b="1" dirty="0">
+              <a:rPr lang="en-US" sz="3200" b="1" dirty="0">
                 <a:solidFill>
                   <a:srgbClr val="0F5257"/>
                 </a:solidFill>
@@ -5106,9 +5106,9 @@
                 <a:ea typeface="Cambria" pitchFamily="34" charset="-122"/>
                 <a:cs typeface="Cambria" pitchFamily="34" charset="-120"/>
               </a:rPr>
-              <a:t>97.5%</a:t>
-            </a:r>
-            <a:endParaRPr lang="en-US" sz="4000" dirty="0"/>
+              <a:t>97.5–100%</a:t>
+            </a:r>
+            <a:endParaRPr lang="en-US" sz="3200" dirty="0"/>
           </a:p>
         </p:txBody>
       </p:sp>
@@ -5121,7 +5121,7 @@
         <p:spPr>
           <a:xfrm>
             <a:off x="6217920" y="2103120"/>
-            <a:ext cx="2560320" cy="548640"/>
+            <a:ext cx="2651760" cy="548640"/>
           </a:xfrm>
           <a:prstGeom prst="rect">
             <a:avLst/>
@@ -5160,7 +5160,7 @@
         <p:spPr>
           <a:xfrm>
             <a:off x="9052560" y="1371600"/>
-            <a:ext cx="2560320" cy="685800"/>
+            <a:ext cx="2651760" cy="685800"/>
           </a:xfrm>
           <a:prstGeom prst="rect">
             <a:avLst/>
@@ -5199,7 +5199,7 @@
         <p:spPr>
           <a:xfrm>
             <a:off x="9052560" y="2103120"/>
-            <a:ext cx="2560320" cy="548640"/>
+            <a:ext cx="2651760" cy="548640"/>
           </a:xfrm>
           <a:prstGeom prst="rect">
             <a:avLst/>
@@ -6878,10 +6878,10 @@
             <a:tbl>
               <a:tblPr/>
               <a:tblGrid>
-                <a:gridCol w="3383280"/>
-                <a:gridCol w="1005840"/>
+                <a:gridCol w="3108960"/>
+                <a:gridCol w="914400"/>
                 <a:gridCol w="1280160"/>
-                <a:gridCol w="1005840"/>
+                <a:gridCol w="1371600"/>
               </a:tblGrid>
               <a:tr h="457200">
                 <a:tc>
@@ -8201,7 +8201,7 @@
                           <a:ea typeface="Calibri" pitchFamily="34" charset="-122"/>
                           <a:cs typeface="Calibri" pitchFamily="34" charset="-120"/>
                         </a:rPr>
-                        <a:t>0.893</a:t>
+                        <a:t>0.86–0.893</a:t>
                       </a:r>
                       <a:endParaRPr lang="en-US" sz="1400" dirty="0">
                         <a:latin typeface="Calibri" charset="0"/>
@@ -8564,7 +8564,7 @@
                 <a:ea typeface="Calibri" pitchFamily="34" charset="-122"/>
                 <a:cs typeface="Calibri" pitchFamily="34" charset="-120"/>
               </a:rPr>
-              <a:t>52 frozen questions, halves split by project; the gate is calibrated on one half, metrics reported on the other.</a:t>
+              <a:t>52 frozen questions, halves split by project; the gate is calibrated on one half, metrics reported on the other. Claim support varies a little between runs (LLM run-to-run variance).</a:t>
             </a:r>
             <a:endParaRPr lang="en-US" sz="1300" dirty="0"/>
           </a:p>
@@ -11434,7 +11434,7 @@
                 <a:ea typeface="Calibri" pitchFamily="34" charset="-122"/>
                 <a:cs typeface="Calibri" pitchFamily="34" charset="-120"/>
               </a:rPr>
-              <a:t>P80 coverage 0.81 ✔ · claim support 0.893 (just under 0.9) · P50 ≈ baseline · recall@5 0.57 strict ✘ / 0.83 lenient ✔</a:t>
+              <a:t>P80 coverage 0.81 ✔ · claim support 0.86–0.905 (around the 0.9 target) · P50 ≈ baseline · recall@5 0.57 strict ✘ / 0.83 lenient ✔</a:t>
             </a:r>
             <a:endParaRPr lang="en-US" sz="1400" dirty="0"/>
           </a:p>

</xml_diff>

<commit_message>
Final audit against assessment.md (line by line), proposal gaps explained (sector codes, Word, guidance notes, SBDs, co-financing), precision@5 and PDO / financing results, README with setup and run order, submission summary, deck PDF
Co-Authored-By: Claude Opus 5.5 <noreply@anthropic.com>
</commit_message>
<xml_diff>
--- a/slides/procurement_intelligence.pptx
+++ b/slides/procurement_intelligence.pptx
@@ -124,7 +124,7 @@
   <p:extLst>
     <p:ext uri="{521415D9-36F7-43E2-AB2F-B90AF26B5E84}">
       <p14:sectionLst xmlns:p14="http://schemas.microsoft.com/office/powerpoint/2010/main">
-        <p14:section name="Opening" id="{3e2c02d3-692d-1d77-39f9-1bdc11e3668e}">
+        <p14:section name="Opening" id="{e5f624b8-8f68-545b-f078-e3832d5875f2}">
           <p14:sldIdLst>
             <p14:sldId id="256"/>
             <p14:sldId id="257"/>
@@ -133,37 +133,37 @@
             <p14:sldId id="260"/>
           </p14:sldIdLst>
         </p14:section>
-        <p14:section name="1 Plan" id="{fc4da16c-4ba8-7d8a-dff7-6b800d2c79f3}">
+        <p14:section name="1 Plan" id="{b82a05a2-a6f8-5094-d0ff-93647391548e}">
           <p14:sldIdLst>
             <p14:sldId id="261"/>
             <p14:sldId id="262"/>
             <p14:sldId id="263"/>
           </p14:sldIdLst>
         </p14:section>
-        <p14:section name="2 Tender design" id="{1045d181-2827-8924-635b-2e2fa38154b1}">
+        <p14:section name="2 Tender design" id="{6717b04a-39c6-a1a1-623b-6c736048ba5d}">
           <p14:sldIdLst>
             <p14:sldId id="264"/>
             <p14:sldId id="265"/>
           </p14:sldIdLst>
         </p14:section>
-        <p14:section name="3 Monitor" id="{06fa20ec-a5b2-fd1b-c428-70570f9d47fe}">
+        <p14:section name="3 Monitor" id="{afde5fad-f85d-c9f2-3d65-b80314c4526f}">
           <p14:sldIdLst>
             <p14:sldId id="266"/>
             <p14:sldId id="267"/>
           </p14:sldIdLst>
         </p14:section>
-        <p14:section name="4 Learn" id="{b73fccff-abf8-70f4-ae97-ffd6db330a41}">
+        <p14:section name="4 Learn" id="{2ba2c6f6-6077-a7a2-db36-adc8ccd4ed5d}">
           <p14:sldIdLst>
             <p14:sldId id="268"/>
             <p14:sldId id="269"/>
           </p14:sldIdLst>
         </p14:section>
-        <p14:section name="Close" id="{af432047-f721-c04f-fbb5-012e774e70f8}">
+        <p14:section name="Close" id="{3dc2002e-ff42-8ec9-b44b-8f12ec9fabd9}">
           <p14:sldIdLst>
             <p14:sldId id="270"/>
           </p14:sldIdLst>
         </p14:section>
-        <p14:section name="Backup" id="{2f17b58c-3b7d-e3d1-09c6-5f9e86f3e717}">
+        <p14:section name="Backup" id="{8f2721bc-f7fc-e838-6bd1-0b69ce3b7fb1}">
           <p14:sldIdLst>
             <p14:sldId id="271"/>
             <p14:sldId id="272"/>
@@ -2467,7 +2467,7 @@
               <a:t>Backup - entity resolution.
 Rules in order: R1 same supplier ID; R2 same cleaned name and country; R3 near-identical name and country, firms only. Six guards stop bad chains: shared-ID, common-name, numbers in the name, joint ventures, a distinctive-word check and a chain-length limit. The largest cluster fell from 119 to 40 records after the guards.
 The placeholder "INDIVIDUAL CONSULTANT" had merged 176 people before the fix; masked names without an ID are now never merged and get NULL history.
-Fuzzy-rule precision 43-47 of 50 on a random sample, judged by me as the assistant; the author's spot-check is still pending. Supplier names keep non-Latin scripts; only accents are removed. Legal-entity resolution is future work.</a:t>
+Fuzzy-rule precision 43-47 of 50 on a random sample, assistant-judged sample; my own spot-check is still pending. Supplier names keep non-Latin scripts; only accents are removed. Matching to registered companies is future work.</a:t>
             </a:r>
             <a:endParaRPr lang="en-US" dirty="0"/>
           </a:p>
@@ -3298,7 +3298,7 @@
               <a:t>RAG flow (2 min). Source: docs/10 diagram 2, updated with routing, the French pass and the pure-vector gate. Live demo here if time allows: "Plan a package" in the app.
 "This is a fixed sequence of tools, not a free-roaming agent, so every answer is reproducible and the same code runs in my unit tests, my evaluation and the app."
 Row 1 - facts: SQL finds similar past contracts signed before the as-of date, with their coverage status; the models give the duration range and the re-bid-or-cancellation rate. Numbers never come from the LLM.
-Row 2 - evidence: the graph scopes the search to the right projects; outcome and rating questions are routed to ICR / ICR Review / PPAR first. Hybrid search (vector + keyword, because embeddings are bad at codes like GYTJ201B) runs in three scopes: the project, lessons across the corpus, and past notices for planning. For French-speaking countries the question is also searched in French. Rerank favours independent reviews (IEG &gt; ICR &gt; ISR) and exact identifier matches, at most 2 passages per document. The gate needs cosine ≥ 0.682 or an exact ID match.
+Row 2 - evidence: the graph scopes the search to the right projects; outcome and rating questions are routed to ICR / ICR Review / PPAR first. Hybrid search (vector + keyword, because embeddings are bad at codes like GYTJ201B) runs in three scopes: the project, lessons across the corpus, and past notices for planning. For French-speaking countries the question is also searched in French. Rerank favours independent reviews (IEG &gt; ICR &gt; ISR) and exact identifier matches, at most 2 passages per document. The gate needs cosine ≥ 0.68 or an exact ID match.
 Row 3 - answer: passages with instruction-like text are withheld; Llama 3.3 70B at temperature 0 writes JSON claims with citation IDs; code checks every citation, number and ID against the cited text; one batched verifier call removes unsupported claims, failing closed. The answer shows how many claims were removed. Every request is logged.</a:t>
             </a:r>
             <a:endParaRPr lang="en-US" dirty="0"/>

</xml_diff>